<commit_message>
Deck cover: real Commons frames on a film strip, the checked pour framed, a shot list with accepted and reshoot rows
Co-Authored-By: Claude Opus 5.5 <noreply@anthropic.com>
</commit_message>
<xml_diff>
--- a/docs/deck/SceneGapEdge_StageI_Proposal.pptx
+++ b/docs/deck/SceneGapEdge_StageI_Proposal.pptx
@@ -131,13 +131,13 @@
   <p:extLst>
     <p:ext uri="{521415D9-36F7-43E2-AB2F-B90AF26B5E84}">
       <p14:sectionLst xmlns:p14="http://schemas.microsoft.com/office/powerpoint/2010/main">
-        <p14:section name="Problem" id="{20e5a9ca-29c1-c199-e5e5-81d081f3afcc}">
+        <p14:section name="Problem" id="{17f594a6-e4c1-0683-8936-8bb0449f3fff}">
           <p14:sldIdLst>
             <p14:sldId id="257"/>
             <p14:sldId id="258"/>
           </p14:sldIdLst>
         </p14:section>
-        <p14:section name="Solution" id="{51254f0d-8345-d7d6-6f60-171015cf08dc}">
+        <p14:section name="Solution" id="{e1a3e19d-ab88-ef00-7439-af459f9f5836}">
           <p14:sldIdLst>
             <p14:sldId id="259"/>
             <p14:sldId id="260"/>
@@ -146,13 +146,13 @@
             <p14:sldId id="263"/>
           </p14:sldIdLst>
         </p14:section>
-        <p14:section name="Hardware" id="{e1490248-59f3-7432-74f6-9cebdf684d91}">
+        <p14:section name="Hardware" id="{b4fb1340-d022-fcc4-c85e-4f06924850a4}">
           <p14:sldIdLst>
             <p14:sldId id="264"/>
             <p14:sldId id="265"/>
           </p14:sldIdLst>
         </p14:section>
-        <p14:section name="Evidence" id="{01de466a-6321-7c60-61ee-8a9e2fc29292}">
+        <p14:section name="Evidence" id="{25e529fd-e69e-fef7-b9b3-1430a3151a49}">
           <p14:sldIdLst>
             <p14:sldId id="266"/>
             <p14:sldId id="267"/>
@@ -161,25 +161,25 @@
             <p14:sldId id="270"/>
           </p14:sldIdLst>
         </p14:section>
-        <p14:section name="Engineering" id="{f2a0a78c-f13d-72d9-7a34-63a13d012caf}">
+        <p14:section name="Engineering" id="{b9c2d9c4-0346-c4cc-5fe1-39d07ef0fb73}">
           <p14:sldIdLst>
             <p14:sldId id="271"/>
           </p14:sldIdLst>
         </p14:section>
-        <p14:section name="Business" id="{6f2026c3-8829-ee9c-efd2-c67ed48aaf48}">
+        <p14:section name="Business" id="{4cd49748-cbae-ad5e-c117-719f0fc55aba}">
           <p14:sldIdLst>
             <p14:sldId id="272"/>
             <p14:sldId id="273"/>
           </p14:sldIdLst>
         </p14:section>
-        <p14:section name="Plan" id="{292a9716-7e87-b6bf-7ecb-b092cb224669}">
+        <p14:section name="Plan" id="{ea574385-e463-6d11-b68c-2126293677ec}">
           <p14:sldIdLst>
             <p14:sldId id="274"/>
             <p14:sldId id="275"/>
             <p14:sldId id="276"/>
           </p14:sldIdLst>
         </p14:section>
-        <p14:section name="Appendix" id="{023827eb-21fb-47e1-4157-331c2d4a5c91}">
+        <p14:section name="Appendix" id="{964ba821-e602-30b5-1da7-8d4d01e884b8}">
           <p14:sldIdLst>
             <p14:sldId id="277"/>
             <p14:sldId id="278"/>
@@ -3395,9 +3395,33 @@
           <a:chExt cx="0" cy="0"/>
         </a:xfrm>
       </p:grpSpPr>
-      <p:sp>
-        <p:nvSpPr>
-          <p:cNvPr id="2" name="Text 0"/>
+      <p:pic>
+        <p:nvPicPr>
+          <p:cNvPr id="2" name="Image 0" descr="C:\Users\yu9br\AppData\Local\Claude-Data\claude_pzs8sxrjxfjjc\scratch-workspaces\c862142c-bcba-48f7-a17f-6dc389d84d09\2507e86a-ea8c-427c-9ed4-55b4f6822600\scratch-2026-10-25-417d2c\decks\scenegap\img\cover_art.png">    </p:cNvPr>
+          <p:cNvPicPr>
+            <a:picLocks noChangeAspect="1"/>
+          </p:cNvPicPr>
+          <p:nvPr/>
+        </p:nvPicPr>
+        <p:blipFill>
+          <a:blip r:embed="rId1"/>
+          <a:stretch>
+            <a:fillRect/>
+          </a:stretch>
+        </p:blipFill>
+        <p:spPr>
+          <a:xfrm>
+            <a:off x="7071055" y="0"/>
+            <a:ext cx="5120640" cy="6858000"/>
+          </a:xfrm>
+          <a:prstGeom prst="rect">
+            <a:avLst/>
+          </a:prstGeom>
+        </p:spPr>
+      </p:pic>
+      <p:sp>
+        <p:nvSpPr>
+          <p:cNvPr id="3" name="Text 0"/>
           <p:cNvSpPr txBox="1"/>
           <p:nvPr/>
         </p:nvSpPr>
@@ -3433,14 +3457,14 @@
       </p:sp>
       <p:pic>
         <p:nvPicPr>
-          <p:cNvPr id="3" name="Image 0" descr="C:\Users\yu9br\AppData\Local\Temp\neo-hIrnKR\a2.png">    </p:cNvPr>
+          <p:cNvPr id="4" name="Image 1" descr="C:\Users\yu9br\AppData\Local\Temp\neo-cbhqvj\a2.png">    </p:cNvPr>
           <p:cNvPicPr>
             <a:picLocks noChangeAspect="1"/>
           </p:cNvPicPr>
           <p:nvPr/>
         </p:nvPicPr>
         <p:blipFill>
-          <a:blip r:embed="rId1"/>
+          <a:blip r:embed="rId2"/>
           <a:stretch>
             <a:fillRect/>
           </a:stretch>
@@ -3457,7 +3481,7 @@
       </p:pic>
       <p:sp>
         <p:nvSpPr>
-          <p:cNvPr id="4" name="Text 1"/>
+          <p:cNvPr id="5" name="Text 1"/>
           <p:cNvSpPr txBox="1"/>
           <p:nvPr/>
         </p:nvSpPr>
@@ -3493,7 +3517,7 @@
       </p:sp>
       <p:sp>
         <p:nvSpPr>
-          <p:cNvPr id="5" name="Shape 2"/>
+          <p:cNvPr id="6" name="Shape 2"/>
           <p:cNvSpPr/>
           <p:nvPr/>
         </p:nvSpPr>
@@ -3524,7 +3548,7 @@
       </p:sp>
       <p:sp>
         <p:nvSpPr>
-          <p:cNvPr id="6" name="Text 3"/>
+          <p:cNvPr id="7" name="Text 3"/>
           <p:cNvSpPr txBox="1"/>
           <p:nvPr/>
         </p:nvSpPr>
@@ -3560,7 +3584,7 @@
       </p:sp>
       <p:sp>
         <p:nvSpPr>
-          <p:cNvPr id="7" name="Shape 4"/>
+          <p:cNvPr id="8" name="Shape 4"/>
           <p:cNvSpPr/>
           <p:nvPr/>
         </p:nvSpPr>
@@ -3591,7 +3615,7 @@
       </p:sp>
       <p:sp>
         <p:nvSpPr>
-          <p:cNvPr id="8" name="Text 5"/>
+          <p:cNvPr id="9" name="Text 5"/>
           <p:cNvSpPr txBox="1"/>
           <p:nvPr/>
         </p:nvSpPr>
@@ -3627,7 +3651,7 @@
       </p:sp>
       <p:sp>
         <p:nvSpPr>
-          <p:cNvPr id="9" name="Shape 6"/>
+          <p:cNvPr id="10" name="Shape 6"/>
           <p:cNvSpPr/>
           <p:nvPr/>
         </p:nvSpPr>
@@ -3658,7 +3682,7 @@
       </p:sp>
       <p:sp>
         <p:nvSpPr>
-          <p:cNvPr id="10" name="Text 7"/>
+          <p:cNvPr id="11" name="Text 7"/>
           <p:cNvSpPr txBox="1"/>
           <p:nvPr/>
         </p:nvSpPr>
@@ -3694,7 +3718,7 @@
       </p:sp>
       <p:sp>
         <p:nvSpPr>
-          <p:cNvPr id="11" name="Shape 8"/>
+          <p:cNvPr id="12" name="Shape 8"/>
           <p:cNvSpPr/>
           <p:nvPr/>
         </p:nvSpPr>
@@ -3725,7 +3749,7 @@
       </p:sp>
       <p:sp>
         <p:nvSpPr>
-          <p:cNvPr id="12" name="Text 9"/>
+          <p:cNvPr id="13" name="Text 9"/>
           <p:cNvSpPr txBox="1"/>
           <p:nvPr/>
         </p:nvSpPr>
@@ -3761,7 +3785,7 @@
       </p:sp>
       <p:sp>
         <p:nvSpPr>
-          <p:cNvPr id="13" name="Text 10"/>
+          <p:cNvPr id="14" name="Text 10"/>
           <p:cNvSpPr txBox="1"/>
           <p:nvPr/>
         </p:nvSpPr>
@@ -6692,7 +6716,7 @@
       </p:sp>
       <p:pic>
         <p:nvPicPr>
-          <p:cNvPr id="5" name="Image 0" descr="C:\Users\yu9br\AppData\Local\Temp\neo-hIrnKR\a3.png">    </p:cNvPr>
+          <p:cNvPr id="5" name="Image 0" descr="C:\Users\yu9br\AppData\Local\Temp\neo-cbhqvj\a3.png">    </p:cNvPr>
           <p:cNvPicPr>
             <a:picLocks noChangeAspect="1"/>
           </p:cNvPicPr>
@@ -6779,7 +6803,7 @@
       </p:sp>
       <p:pic>
         <p:nvPicPr>
-          <p:cNvPr id="8" name="Image 1" descr="C:\Users\yu9br\AppData\Local\Temp\neo-hIrnKR\a4.png">    </p:cNvPr>
+          <p:cNvPr id="8" name="Image 1" descr="C:\Users\yu9br\AppData\Local\Temp\neo-cbhqvj\a4.png">    </p:cNvPr>
           <p:cNvPicPr>
             <a:picLocks noChangeAspect="1"/>
           </p:cNvPicPr>
@@ -6866,7 +6890,7 @@
       </p:sp>
       <p:pic>
         <p:nvPicPr>
-          <p:cNvPr id="11" name="Image 2" descr="C:\Users\yu9br\AppData\Local\Temp\neo-hIrnKR\a5.png">    </p:cNvPr>
+          <p:cNvPr id="11" name="Image 2" descr="C:\Users\yu9br\AppData\Local\Temp\neo-cbhqvj\a5.png">    </p:cNvPr>
           <p:cNvPicPr>
             <a:picLocks noChangeAspect="1"/>
           </p:cNvPicPr>
@@ -6953,7 +6977,7 @@
       </p:sp>
       <p:pic>
         <p:nvPicPr>
-          <p:cNvPr id="14" name="Image 3" descr="C:\Users\yu9br\AppData\Local\Temp\neo-hIrnKR\a6.png">    </p:cNvPr>
+          <p:cNvPr id="14" name="Image 3" descr="C:\Users\yu9br\AppData\Local\Temp\neo-cbhqvj\a6.png">    </p:cNvPr>
           <p:cNvPicPr>
             <a:picLocks noChangeAspect="1"/>
           </p:cNvPicPr>
@@ -16264,7 +16288,7 @@
       </p:grpSpPr>
       <p:pic>
         <p:nvPicPr>
-          <p:cNvPr id="2" name="Image 0" descr="C:\Users\yu9br\AppData\Local\Temp\neo-hIrnKR\a7.png">    </p:cNvPr>
+          <p:cNvPr id="2" name="Image 0" descr="C:\Users\yu9br\AppData\Local\Temp\neo-cbhqvj\a7.png">    </p:cNvPr>
           <p:cNvPicPr>
             <a:picLocks noChangeAspect="1"/>
           </p:cNvPicPr>

</xml_diff>